<commit_message>
Add live Streamlit Cloud app URL to README, Report PDF, and Presentation PPT
</commit_message>
<xml_diff>
--- a/PPT.pptx
+++ b/PPT.pptx
@@ -5,18 +5,18 @@
     <p:sldMasterId id="2147483648" r:id="rId1"/>
   </p:sldMasterIdLst>
   <p:sldIdLst>
-    <p:sldId id="256" r:id="rId2"/>
-    <p:sldId id="257" r:id="rId3"/>
-    <p:sldId id="258" r:id="rId4"/>
-    <p:sldId id="259" r:id="rId5"/>
-    <p:sldId id="260" r:id="rId6"/>
-    <p:sldId id="261" r:id="rId7"/>
-    <p:sldId id="262" r:id="rId8"/>
-    <p:sldId id="263" r:id="rId9"/>
-    <p:sldId id="264" r:id="rId10"/>
-    <p:sldId id="265" r:id="rId11"/>
+    <p:sldId id="256" r:id="rId7"/>
+    <p:sldId id="257" r:id="rId8"/>
+    <p:sldId id="258" r:id="rId9"/>
+    <p:sldId id="259" r:id="rId10"/>
+    <p:sldId id="260" r:id="rId11"/>
+    <p:sldId id="261" r:id="rId12"/>
+    <p:sldId id="262" r:id="rId13"/>
+    <p:sldId id="263" r:id="rId14"/>
+    <p:sldId id="264" r:id="rId15"/>
+    <p:sldId id="265" r:id="rId16"/>
   </p:sldIdLst>
-  <p:sldSz cx="12192000" cy="6858000"/>
+  <p:sldSz cx="12191695" cy="6858000" type="screen4x3"/>
   <p:notesSz cx="6858000" cy="9144000"/>
   <p:defaultTextStyle>
     <a:defPPr>
@@ -113,22 +113,6 @@
       </a:defRPr>
     </a:lvl9pPr>
   </p:defaultTextStyle>
-  <p:extLst>
-    <p:ext uri="{EFAFB233-063F-42B5-8137-9DF3F51BA10A}">
-      <p15:sldGuideLst xmlns:p15="http://schemas.microsoft.com/office/powerpoint/2012/main">
-        <p15:guide id="1" orient="horz" pos="2160">
-          <p15:clr>
-            <a:srgbClr val="A4A3A4"/>
-          </p15:clr>
-        </p15:guide>
-        <p15:guide id="2" pos="2880">
-          <p15:clr>
-            <a:srgbClr val="A4A3A4"/>
-          </p15:clr>
-        </p15:guide>
-      </p15:sldGuideLst>
-    </p:ext>
-  </p:extLst>
 </p:presentation>
 </file>
 
@@ -170,9 +154,10 @@
           <a:lstStyle/>
           <a:p>
             <a:r>
-              <a:rPr lang="en-US"/>
+              <a:rPr lang="en-US" smtClean="0"/>
               <a:t>Click to edit Master title style</a:t>
             </a:r>
+            <a:endParaRPr lang="en-US"/>
           </a:p>
         </p:txBody>
       </p:sp>
@@ -288,9 +273,10 @@
           </a:lstStyle>
           <a:p>
             <a:r>
-              <a:rPr lang="en-US"/>
+              <a:rPr lang="en-US" smtClean="0"/>
               <a:t>Click to edit Master subtitle style</a:t>
             </a:r>
+            <a:endParaRPr lang="en-US"/>
           </a:p>
         </p:txBody>
       </p:sp>
@@ -311,7 +297,7 @@
           <a:p>
             <a:fld id="{5BCAD085-E8A6-8845-BD4E-CB4CCA059FC4}" type="datetimeFigureOut">
               <a:rPr lang="en-US" smtClean="0"/>
-              <a:t>2026-07-22</a:t>
+              <a:t>1/27/13</a:t>
             </a:fld>
             <a:endParaRPr lang="en-US"/>
           </a:p>
@@ -405,9 +391,10 @@
           <a:lstStyle/>
           <a:p>
             <a:r>
-              <a:rPr lang="en-US"/>
+              <a:rPr lang="en-US" smtClean="0"/>
               <a:t>Click to edit Master title style</a:t>
             </a:r>
+            <a:endParaRPr lang="en-US"/>
           </a:p>
         </p:txBody>
       </p:sp>
@@ -428,37 +415,38 @@
           <a:p>
             <a:pPr lvl="0"/>
             <a:r>
-              <a:rPr lang="en-US"/>
+              <a:rPr lang="en-US" smtClean="0"/>
               <a:t>Click to edit Master text styles</a:t>
             </a:r>
           </a:p>
           <a:p>
             <a:pPr lvl="1"/>
             <a:r>
-              <a:rPr lang="en-US"/>
+              <a:rPr lang="en-US" smtClean="0"/>
               <a:t>Second level</a:t>
             </a:r>
           </a:p>
           <a:p>
             <a:pPr lvl="2"/>
             <a:r>
-              <a:rPr lang="en-US"/>
+              <a:rPr lang="en-US" smtClean="0"/>
               <a:t>Third level</a:t>
             </a:r>
           </a:p>
           <a:p>
             <a:pPr lvl="3"/>
             <a:r>
-              <a:rPr lang="en-US"/>
+              <a:rPr lang="en-US" smtClean="0"/>
               <a:t>Fourth level</a:t>
             </a:r>
           </a:p>
           <a:p>
             <a:pPr lvl="4"/>
             <a:r>
-              <a:rPr lang="en-US"/>
+              <a:rPr lang="en-US" smtClean="0"/>
               <a:t>Fifth level</a:t>
             </a:r>
+            <a:endParaRPr lang="en-US"/>
           </a:p>
         </p:txBody>
       </p:sp>
@@ -479,7 +467,7 @@
           <a:p>
             <a:fld id="{5BCAD085-E8A6-8845-BD4E-CB4CCA059FC4}" type="datetimeFigureOut">
               <a:rPr lang="en-US" smtClean="0"/>
-              <a:t>2026-07-22</a:t>
+              <a:t>1/27/13</a:t>
             </a:fld>
             <a:endParaRPr lang="en-US"/>
           </a:p>
@@ -578,9 +566,10 @@
           <a:lstStyle/>
           <a:p>
             <a:r>
-              <a:rPr lang="en-US"/>
+              <a:rPr lang="en-US" smtClean="0"/>
               <a:t>Click to edit Master title style</a:t>
             </a:r>
+            <a:endParaRPr lang="en-US"/>
           </a:p>
         </p:txBody>
       </p:sp>
@@ -606,37 +595,38 @@
           <a:p>
             <a:pPr lvl="0"/>
             <a:r>
-              <a:rPr lang="en-US"/>
+              <a:rPr lang="en-US" smtClean="0"/>
               <a:t>Click to edit Master text styles</a:t>
             </a:r>
           </a:p>
           <a:p>
             <a:pPr lvl="1"/>
             <a:r>
-              <a:rPr lang="en-US"/>
+              <a:rPr lang="en-US" smtClean="0"/>
               <a:t>Second level</a:t>
             </a:r>
           </a:p>
           <a:p>
             <a:pPr lvl="2"/>
             <a:r>
-              <a:rPr lang="en-US"/>
+              <a:rPr lang="en-US" smtClean="0"/>
               <a:t>Third level</a:t>
             </a:r>
           </a:p>
           <a:p>
             <a:pPr lvl="3"/>
             <a:r>
-              <a:rPr lang="en-US"/>
+              <a:rPr lang="en-US" smtClean="0"/>
               <a:t>Fourth level</a:t>
             </a:r>
           </a:p>
           <a:p>
             <a:pPr lvl="4"/>
             <a:r>
-              <a:rPr lang="en-US"/>
+              <a:rPr lang="en-US" smtClean="0"/>
               <a:t>Fifth level</a:t>
             </a:r>
+            <a:endParaRPr lang="en-US"/>
           </a:p>
         </p:txBody>
       </p:sp>
@@ -657,7 +647,7 @@
           <a:p>
             <a:fld id="{5BCAD085-E8A6-8845-BD4E-CB4CCA059FC4}" type="datetimeFigureOut">
               <a:rPr lang="en-US" smtClean="0"/>
-              <a:t>2026-07-22</a:t>
+              <a:t>1/27/13</a:t>
             </a:fld>
             <a:endParaRPr lang="en-US"/>
           </a:p>
@@ -751,9 +741,10 @@
           <a:lstStyle/>
           <a:p>
             <a:r>
-              <a:rPr lang="en-US"/>
+              <a:rPr lang="en-US" smtClean="0"/>
               <a:t>Click to edit Master title style</a:t>
             </a:r>
+            <a:endParaRPr lang="en-US"/>
           </a:p>
         </p:txBody>
       </p:sp>
@@ -774,37 +765,38 @@
           <a:p>
             <a:pPr lvl="0"/>
             <a:r>
-              <a:rPr lang="en-US"/>
+              <a:rPr lang="en-US" smtClean="0"/>
               <a:t>Click to edit Master text styles</a:t>
             </a:r>
           </a:p>
           <a:p>
             <a:pPr lvl="1"/>
             <a:r>
-              <a:rPr lang="en-US"/>
+              <a:rPr lang="en-US" smtClean="0"/>
               <a:t>Second level</a:t>
             </a:r>
           </a:p>
           <a:p>
             <a:pPr lvl="2"/>
             <a:r>
-              <a:rPr lang="en-US"/>
+              <a:rPr lang="en-US" smtClean="0"/>
               <a:t>Third level</a:t>
             </a:r>
           </a:p>
           <a:p>
             <a:pPr lvl="3"/>
             <a:r>
-              <a:rPr lang="en-US"/>
+              <a:rPr lang="en-US" smtClean="0"/>
               <a:t>Fourth level</a:t>
             </a:r>
           </a:p>
           <a:p>
             <a:pPr lvl="4"/>
             <a:r>
-              <a:rPr lang="en-US"/>
+              <a:rPr lang="en-US" smtClean="0"/>
               <a:t>Fifth level</a:t>
             </a:r>
+            <a:endParaRPr lang="en-US"/>
           </a:p>
         </p:txBody>
       </p:sp>
@@ -825,7 +817,7 @@
           <a:p>
             <a:fld id="{5BCAD085-E8A6-8845-BD4E-CB4CCA059FC4}" type="datetimeFigureOut">
               <a:rPr lang="en-US" smtClean="0"/>
-              <a:t>2026-07-22</a:t>
+              <a:t>1/27/13</a:t>
             </a:fld>
             <a:endParaRPr lang="en-US"/>
           </a:p>
@@ -928,9 +920,10 @@
           </a:lstStyle>
           <a:p>
             <a:r>
-              <a:rPr lang="en-US"/>
+              <a:rPr lang="en-US" smtClean="0"/>
               <a:t>Click to edit Master title style</a:t>
             </a:r>
+            <a:endParaRPr lang="en-US"/>
           </a:p>
         </p:txBody>
       </p:sp>
@@ -1047,7 +1040,7 @@
           <a:p>
             <a:pPr lvl="0"/>
             <a:r>
-              <a:rPr lang="en-US"/>
+              <a:rPr lang="en-US" smtClean="0"/>
               <a:t>Click to edit Master text styles</a:t>
             </a:r>
           </a:p>
@@ -1070,7 +1063,7 @@
           <a:p>
             <a:fld id="{5BCAD085-E8A6-8845-BD4E-CB4CCA059FC4}" type="datetimeFigureOut">
               <a:rPr lang="en-US" smtClean="0"/>
-              <a:t>2026-07-22</a:t>
+              <a:t>1/27/13</a:t>
             </a:fld>
             <a:endParaRPr lang="en-US"/>
           </a:p>
@@ -1164,9 +1157,10 @@
           <a:lstStyle/>
           <a:p>
             <a:r>
-              <a:rPr lang="en-US"/>
+              <a:rPr lang="en-US" smtClean="0"/>
               <a:t>Click to edit Master title style</a:t>
             </a:r>
+            <a:endParaRPr lang="en-US"/>
           </a:p>
         </p:txBody>
       </p:sp>
@@ -1220,37 +1214,38 @@
           <a:p>
             <a:pPr lvl="0"/>
             <a:r>
-              <a:rPr lang="en-US"/>
+              <a:rPr lang="en-US" smtClean="0"/>
               <a:t>Click to edit Master text styles</a:t>
             </a:r>
           </a:p>
           <a:p>
             <a:pPr lvl="1"/>
             <a:r>
-              <a:rPr lang="en-US"/>
+              <a:rPr lang="en-US" smtClean="0"/>
               <a:t>Second level</a:t>
             </a:r>
           </a:p>
           <a:p>
             <a:pPr lvl="2"/>
             <a:r>
-              <a:rPr lang="en-US"/>
+              <a:rPr lang="en-US" smtClean="0"/>
               <a:t>Third level</a:t>
             </a:r>
           </a:p>
           <a:p>
             <a:pPr lvl="3"/>
             <a:r>
-              <a:rPr lang="en-US"/>
+              <a:rPr lang="en-US" smtClean="0"/>
               <a:t>Fourth level</a:t>
             </a:r>
           </a:p>
           <a:p>
             <a:pPr lvl="4"/>
             <a:r>
-              <a:rPr lang="en-US"/>
+              <a:rPr lang="en-US" smtClean="0"/>
               <a:t>Fifth level</a:t>
             </a:r>
+            <a:endParaRPr lang="en-US"/>
           </a:p>
         </p:txBody>
       </p:sp>
@@ -1304,37 +1299,38 @@
           <a:p>
             <a:pPr lvl="0"/>
             <a:r>
-              <a:rPr lang="en-US"/>
+              <a:rPr lang="en-US" smtClean="0"/>
               <a:t>Click to edit Master text styles</a:t>
             </a:r>
           </a:p>
           <a:p>
             <a:pPr lvl="1"/>
             <a:r>
-              <a:rPr lang="en-US"/>
+              <a:rPr lang="en-US" smtClean="0"/>
               <a:t>Second level</a:t>
             </a:r>
           </a:p>
           <a:p>
             <a:pPr lvl="2"/>
             <a:r>
-              <a:rPr lang="en-US"/>
+              <a:rPr lang="en-US" smtClean="0"/>
               <a:t>Third level</a:t>
             </a:r>
           </a:p>
           <a:p>
             <a:pPr lvl="3"/>
             <a:r>
-              <a:rPr lang="en-US"/>
+              <a:rPr lang="en-US" smtClean="0"/>
               <a:t>Fourth level</a:t>
             </a:r>
           </a:p>
           <a:p>
             <a:pPr lvl="4"/>
             <a:r>
-              <a:rPr lang="en-US"/>
+              <a:rPr lang="en-US" smtClean="0"/>
               <a:t>Fifth level</a:t>
             </a:r>
+            <a:endParaRPr lang="en-US"/>
           </a:p>
         </p:txBody>
       </p:sp>
@@ -1355,7 +1351,7 @@
           <a:p>
             <a:fld id="{5BCAD085-E8A6-8845-BD4E-CB4CCA059FC4}" type="datetimeFigureOut">
               <a:rPr lang="en-US" smtClean="0"/>
-              <a:t>2026-07-22</a:t>
+              <a:t>1/27/13</a:t>
             </a:fld>
             <a:endParaRPr lang="en-US"/>
           </a:p>
@@ -1453,9 +1449,10 @@
           </a:lstStyle>
           <a:p>
             <a:r>
-              <a:rPr lang="en-US"/>
+              <a:rPr lang="en-US" smtClean="0"/>
               <a:t>Click to edit Master title style</a:t>
             </a:r>
+            <a:endParaRPr lang="en-US"/>
           </a:p>
         </p:txBody>
       </p:sp>
@@ -1518,7 +1515,7 @@
           <a:p>
             <a:pPr lvl="0"/>
             <a:r>
-              <a:rPr lang="en-US"/>
+              <a:rPr lang="en-US" smtClean="0"/>
               <a:t>Click to edit Master text styles</a:t>
             </a:r>
           </a:p>
@@ -1574,37 +1571,38 @@
           <a:p>
             <a:pPr lvl="0"/>
             <a:r>
-              <a:rPr lang="en-US"/>
+              <a:rPr lang="en-US" smtClean="0"/>
               <a:t>Click to edit Master text styles</a:t>
             </a:r>
           </a:p>
           <a:p>
             <a:pPr lvl="1"/>
             <a:r>
-              <a:rPr lang="en-US"/>
+              <a:rPr lang="en-US" smtClean="0"/>
               <a:t>Second level</a:t>
             </a:r>
           </a:p>
           <a:p>
             <a:pPr lvl="2"/>
             <a:r>
-              <a:rPr lang="en-US"/>
+              <a:rPr lang="en-US" smtClean="0"/>
               <a:t>Third level</a:t>
             </a:r>
           </a:p>
           <a:p>
             <a:pPr lvl="3"/>
             <a:r>
-              <a:rPr lang="en-US"/>
+              <a:rPr lang="en-US" smtClean="0"/>
               <a:t>Fourth level</a:t>
             </a:r>
           </a:p>
           <a:p>
             <a:pPr lvl="4"/>
             <a:r>
-              <a:rPr lang="en-US"/>
+              <a:rPr lang="en-US" smtClean="0"/>
               <a:t>Fifth level</a:t>
             </a:r>
+            <a:endParaRPr lang="en-US"/>
           </a:p>
         </p:txBody>
       </p:sp>
@@ -1667,7 +1665,7 @@
           <a:p>
             <a:pPr lvl="0"/>
             <a:r>
-              <a:rPr lang="en-US"/>
+              <a:rPr lang="en-US" smtClean="0"/>
               <a:t>Click to edit Master text styles</a:t>
             </a:r>
           </a:p>
@@ -1723,37 +1721,38 @@
           <a:p>
             <a:pPr lvl="0"/>
             <a:r>
-              <a:rPr lang="en-US"/>
+              <a:rPr lang="en-US" smtClean="0"/>
               <a:t>Click to edit Master text styles</a:t>
             </a:r>
           </a:p>
           <a:p>
             <a:pPr lvl="1"/>
             <a:r>
-              <a:rPr lang="en-US"/>
+              <a:rPr lang="en-US" smtClean="0"/>
               <a:t>Second level</a:t>
             </a:r>
           </a:p>
           <a:p>
             <a:pPr lvl="2"/>
             <a:r>
-              <a:rPr lang="en-US"/>
+              <a:rPr lang="en-US" smtClean="0"/>
               <a:t>Third level</a:t>
             </a:r>
           </a:p>
           <a:p>
             <a:pPr lvl="3"/>
             <a:r>
-              <a:rPr lang="en-US"/>
+              <a:rPr lang="en-US" smtClean="0"/>
               <a:t>Fourth level</a:t>
             </a:r>
           </a:p>
           <a:p>
             <a:pPr lvl="4"/>
             <a:r>
-              <a:rPr lang="en-US"/>
+              <a:rPr lang="en-US" smtClean="0"/>
               <a:t>Fifth level</a:t>
             </a:r>
+            <a:endParaRPr lang="en-US"/>
           </a:p>
         </p:txBody>
       </p:sp>
@@ -1774,7 +1773,7 @@
           <a:p>
             <a:fld id="{5BCAD085-E8A6-8845-BD4E-CB4CCA059FC4}" type="datetimeFigureOut">
               <a:rPr lang="en-US" smtClean="0"/>
-              <a:t>2026-07-22</a:t>
+              <a:t>1/27/13</a:t>
             </a:fld>
             <a:endParaRPr lang="en-US"/>
           </a:p>
@@ -1868,9 +1867,10 @@
           <a:lstStyle/>
           <a:p>
             <a:r>
-              <a:rPr lang="en-US"/>
+              <a:rPr lang="en-US" smtClean="0"/>
               <a:t>Click to edit Master title style</a:t>
             </a:r>
+            <a:endParaRPr lang="en-US"/>
           </a:p>
         </p:txBody>
       </p:sp>
@@ -1891,7 +1891,7 @@
           <a:p>
             <a:fld id="{5BCAD085-E8A6-8845-BD4E-CB4CCA059FC4}" type="datetimeFigureOut">
               <a:rPr lang="en-US" smtClean="0"/>
-              <a:t>2026-07-22</a:t>
+              <a:t>1/27/13</a:t>
             </a:fld>
             <a:endParaRPr lang="en-US"/>
           </a:p>
@@ -1986,7 +1986,7 @@
           <a:p>
             <a:fld id="{5BCAD085-E8A6-8845-BD4E-CB4CCA059FC4}" type="datetimeFigureOut">
               <a:rPr lang="en-US" smtClean="0"/>
-              <a:t>2026-07-22</a:t>
+              <a:t>1/27/13</a:t>
             </a:fld>
             <a:endParaRPr lang="en-US"/>
           </a:p>
@@ -2089,9 +2089,10 @@
           </a:lstStyle>
           <a:p>
             <a:r>
-              <a:rPr lang="en-US"/>
+              <a:rPr lang="en-US" smtClean="0"/>
               <a:t>Click to edit Master title style</a:t>
             </a:r>
+            <a:endParaRPr lang="en-US"/>
           </a:p>
         </p:txBody>
       </p:sp>
@@ -2145,37 +2146,38 @@
           <a:p>
             <a:pPr lvl="0"/>
             <a:r>
-              <a:rPr lang="en-US"/>
+              <a:rPr lang="en-US" smtClean="0"/>
               <a:t>Click to edit Master text styles</a:t>
             </a:r>
           </a:p>
           <a:p>
             <a:pPr lvl="1"/>
             <a:r>
-              <a:rPr lang="en-US"/>
+              <a:rPr lang="en-US" smtClean="0"/>
               <a:t>Second level</a:t>
             </a:r>
           </a:p>
           <a:p>
             <a:pPr lvl="2"/>
             <a:r>
-              <a:rPr lang="en-US"/>
+              <a:rPr lang="en-US" smtClean="0"/>
               <a:t>Third level</a:t>
             </a:r>
           </a:p>
           <a:p>
             <a:pPr lvl="3"/>
             <a:r>
-              <a:rPr lang="en-US"/>
+              <a:rPr lang="en-US" smtClean="0"/>
               <a:t>Fourth level</a:t>
             </a:r>
           </a:p>
           <a:p>
             <a:pPr lvl="4"/>
             <a:r>
-              <a:rPr lang="en-US"/>
+              <a:rPr lang="en-US" smtClean="0"/>
               <a:t>Fifth level</a:t>
             </a:r>
+            <a:endParaRPr lang="en-US"/>
           </a:p>
         </p:txBody>
       </p:sp>
@@ -2238,7 +2240,7 @@
           <a:p>
             <a:pPr lvl="0"/>
             <a:r>
-              <a:rPr lang="en-US"/>
+              <a:rPr lang="en-US" smtClean="0"/>
               <a:t>Click to edit Master text styles</a:t>
             </a:r>
           </a:p>
@@ -2261,7 +2263,7 @@
           <a:p>
             <a:fld id="{5BCAD085-E8A6-8845-BD4E-CB4CCA059FC4}" type="datetimeFigureOut">
               <a:rPr lang="en-US" smtClean="0"/>
-              <a:t>2026-07-22</a:t>
+              <a:t>1/27/13</a:t>
             </a:fld>
             <a:endParaRPr lang="en-US"/>
           </a:p>
@@ -2364,9 +2366,10 @@
           </a:lstStyle>
           <a:p>
             <a:r>
-              <a:rPr lang="en-US"/>
+              <a:rPr lang="en-US" smtClean="0"/>
               <a:t>Click to edit Master title style</a:t>
             </a:r>
+            <a:endParaRPr lang="en-US"/>
           </a:p>
         </p:txBody>
       </p:sp>
@@ -2490,7 +2493,7 @@
           <a:p>
             <a:pPr lvl="0"/>
             <a:r>
-              <a:rPr lang="en-US"/>
+              <a:rPr lang="en-US" smtClean="0"/>
               <a:t>Click to edit Master text styles</a:t>
             </a:r>
           </a:p>
@@ -2513,7 +2516,7 @@
           <a:p>
             <a:fld id="{5BCAD085-E8A6-8845-BD4E-CB4CCA059FC4}" type="datetimeFigureOut">
               <a:rPr lang="en-US" smtClean="0"/>
-              <a:t>2026-07-22</a:t>
+              <a:t>1/27/13</a:t>
             </a:fld>
             <a:endParaRPr lang="en-US"/>
           </a:p>
@@ -2622,9 +2625,10 @@
           <a:lstStyle/>
           <a:p>
             <a:r>
-              <a:rPr lang="en-US"/>
+              <a:rPr lang="en-US" smtClean="0"/>
               <a:t>Click to edit Master title style</a:t>
             </a:r>
+            <a:endParaRPr lang="en-US"/>
           </a:p>
         </p:txBody>
       </p:sp>
@@ -2655,37 +2659,38 @@
           <a:p>
             <a:pPr lvl="0"/>
             <a:r>
-              <a:rPr lang="en-US"/>
+              <a:rPr lang="en-US" smtClean="0"/>
               <a:t>Click to edit Master text styles</a:t>
             </a:r>
           </a:p>
           <a:p>
             <a:pPr lvl="1"/>
             <a:r>
-              <a:rPr lang="en-US"/>
+              <a:rPr lang="en-US" smtClean="0"/>
               <a:t>Second level</a:t>
             </a:r>
           </a:p>
           <a:p>
             <a:pPr lvl="2"/>
             <a:r>
-              <a:rPr lang="en-US"/>
+              <a:rPr lang="en-US" smtClean="0"/>
               <a:t>Third level</a:t>
             </a:r>
           </a:p>
           <a:p>
             <a:pPr lvl="3"/>
             <a:r>
-              <a:rPr lang="en-US"/>
+              <a:rPr lang="en-US" smtClean="0"/>
               <a:t>Fourth level</a:t>
             </a:r>
           </a:p>
           <a:p>
             <a:pPr lvl="4"/>
             <a:r>
-              <a:rPr lang="en-US"/>
+              <a:rPr lang="en-US" smtClean="0"/>
               <a:t>Fifth level</a:t>
             </a:r>
+            <a:endParaRPr lang="en-US"/>
           </a:p>
         </p:txBody>
       </p:sp>
@@ -2724,7 +2729,7 @@
           <a:p>
             <a:fld id="{5BCAD085-E8A6-8845-BD4E-CB4CCA059FC4}" type="datetimeFigureOut">
               <a:rPr lang="en-US" smtClean="0"/>
-              <a:t>2026-07-22</a:t>
+              <a:t>1/27/13</a:t>
             </a:fld>
             <a:endParaRPr lang="en-US"/>
           </a:p>
@@ -3083,7 +3088,7 @@
 </file>
 
 <file path=ppt/slides/slide1.xml><?xml version="1.0" encoding="utf-8"?>
-<p:sld xmlns:a="http://schemas.openxmlformats.org/drawingml/2006/main" xmlns:r="http://schemas.openxmlformats.org/officeDocument/2006/relationships" xmlns:p="http://schemas.openxmlformats.org/presentationml/2006/main">
+<p:sld xmlns:a="http://schemas.openxmlformats.org/drawingml/2006/main" xmlns:p="http://schemas.openxmlformats.org/presentationml/2006/main" xmlns:r="http://schemas.openxmlformats.org/officeDocument/2006/relationships">
   <p:cSld>
     <p:spTree>
       <p:nvGrpSpPr>
@@ -3091,14 +3096,7 @@
         <p:cNvGrpSpPr/>
         <p:nvPr/>
       </p:nvGrpSpPr>
-      <p:grpSpPr>
-        <a:xfrm>
-          <a:off x="0" y="0"/>
-          <a:ext cx="0" cy="0"/>
-          <a:chOff x="0" y="0"/>
-          <a:chExt cx="0" cy="0"/>
-        </a:xfrm>
-      </p:grpSpPr>
+      <p:grpSpPr/>
       <p:sp>
         <p:nvSpPr>
           <p:cNvPr id="2" name="Rectangle 1"/>
@@ -3139,7 +3137,6 @@
           <a:lstStyle/>
           <a:p>
             <a:pPr algn="ctr"/>
-            <a:endParaRPr/>
           </a:p>
         </p:txBody>
       </p:sp>
@@ -3151,7 +3148,7 @@
         </p:nvSpPr>
         <p:spPr>
           <a:xfrm>
-            <a:off x="914400" y="1645920"/>
+            <a:off x="914400" y="1371600"/>
             <a:ext cx="1371600" cy="73152"/>
           </a:xfrm>
           <a:prstGeom prst="rect">
@@ -3183,7 +3180,6 @@
           <a:lstStyle/>
           <a:p>
             <a:pPr algn="ctr"/>
-            <a:endParaRPr/>
           </a:p>
         </p:txBody>
       </p:sp>
@@ -3195,8 +3191,8 @@
         </p:nvSpPr>
         <p:spPr>
           <a:xfrm>
-            <a:off x="914400" y="1920240"/>
-            <a:ext cx="10332720" cy="3200400"/>
+            <a:off x="914400" y="1645920"/>
+            <a:ext cx="10332720" cy="4572000"/>
           </a:xfrm>
           <a:prstGeom prst="rect">
             <a:avLst/>
@@ -3224,33 +3220,48 @@
           <a:p>
             <a:pPr>
               <a:spcBef>
+                <a:spcPts val="1200"/>
+              </a:spcBef>
+              <a:defRPr sz="2000">
+                <a:solidFill>
+                  <a:srgbClr val="D97757"/>
+                </a:solidFill>
+                <a:latin typeface="Arial"/>
+              </a:defRPr>
+            </a:pPr>
+            <a:r>
+              <a:t>Grounded Industrial Knowledge Intelligence via Hybrid GraphRAG &amp; Honest Abstention</a:t>
+            </a:r>
+          </a:p>
+          <a:p>
+            <a:pPr>
+              <a:spcBef>
+                <a:spcPts val="1600"/>
+              </a:spcBef>
+              <a:defRPr sz="1400">
+                <a:solidFill>
+                  <a:srgbClr val="EEEEEE"/>
+                </a:solidFill>
+                <a:latin typeface="Arial"/>
+              </a:defRPr>
+            </a:pPr>
+            <a:r>
+              <a:t>ET AI Hackathon 2026 — Problem Statement #8</a:t>
+            </a:r>
+          </a:p>
+          <a:p>
+            <a:pPr>
+              <a:spcBef>
                 <a:spcPts val="1400"/>
               </a:spcBef>
-              <a:defRPr sz="2200">
-                <a:solidFill>
-                  <a:srgbClr val="D97757"/>
-                </a:solidFill>
-                <a:latin typeface="Arial"/>
-              </a:defRPr>
-            </a:pPr>
-            <a:r>
-              <a:t>Grounded Industrial Knowledge Intelligence via Hybrid GraphRAG &amp; Honest Abstention</a:t>
-            </a:r>
-          </a:p>
-          <a:p>
-            <a:pPr>
-              <a:spcBef>
-                <a:spcPts val="2800"/>
-              </a:spcBef>
-              <a:defRPr sz="1400">
-                <a:solidFill>
-                  <a:srgbClr val="EEEEEE"/>
-                </a:solidFill>
-                <a:latin typeface="Arial"/>
-              </a:defRPr>
-            </a:pPr>
-            <a:r>
-              <a:t>ET AI Hackathon 2026 — Problem Statement #8: Industrial Knowledge Intelligence</a:t>
+              <a:defRPr sz="1400" b="1">
+                <a:solidFill>
+                  <a:srgbClr val="059669"/>
+                </a:solidFill>
+              </a:defRPr>
+            </a:pPr>
+            <a:r>
+              <a:t>🚀 Live Application: https://plant-operation-brain-amduv45vm9kibjyjwkwkmh.streamlit.app</a:t>
             </a:r>
           </a:p>
         </p:txBody>
@@ -3271,7 +3282,7 @@
         </p:blipFill>
         <p:spPr>
           <a:xfrm>
-            <a:off x="8499565" y="3244565"/>
+            <a:off x="8412480" y="1645920"/>
             <a:ext cx="3474720" cy="3474720"/>
           </a:xfrm>
           <a:prstGeom prst="rect">
@@ -3288,7 +3299,7 @@
 </file>
 
 <file path=ppt/slides/slide10.xml><?xml version="1.0" encoding="utf-8"?>
-<p:sld xmlns:a="http://schemas.openxmlformats.org/drawingml/2006/main" xmlns:r="http://schemas.openxmlformats.org/officeDocument/2006/relationships" xmlns:p="http://schemas.openxmlformats.org/presentationml/2006/main">
+<p:sld xmlns:a="http://schemas.openxmlformats.org/drawingml/2006/main" xmlns:p="http://schemas.openxmlformats.org/presentationml/2006/main" xmlns:r="http://schemas.openxmlformats.org/officeDocument/2006/relationships">
   <p:cSld>
     <p:spTree>
       <p:nvGrpSpPr>
@@ -3296,14 +3307,7 @@
         <p:cNvGrpSpPr/>
         <p:nvPr/>
       </p:nvGrpSpPr>
-      <p:grpSpPr>
-        <a:xfrm>
-          <a:off x="0" y="0"/>
-          <a:ext cx="0" cy="0"/>
-          <a:chOff x="0" y="0"/>
-          <a:chExt cx="0" cy="0"/>
-        </a:xfrm>
-      </p:grpSpPr>
+      <p:grpSpPr/>
       <p:sp>
         <p:nvSpPr>
           <p:cNvPr id="2" name="Rectangle 1"/>
@@ -3344,7 +3348,6 @@
           <a:lstStyle/>
           <a:p>
             <a:pPr algn="ctr"/>
-            <a:endParaRPr/>
           </a:p>
         </p:txBody>
       </p:sp>
@@ -3356,8 +3359,8 @@
         </p:nvSpPr>
         <p:spPr>
           <a:xfrm>
-            <a:off x="914400" y="1371600"/>
-            <a:ext cx="10332720" cy="4114800"/>
+            <a:off x="914400" y="1097280"/>
+            <a:ext cx="10332720" cy="4754880"/>
           </a:xfrm>
           <a:prstGeom prst="rect">
             <a:avLst/>
@@ -3385,7 +3388,7 @@
           <a:p>
             <a:pPr>
               <a:spcBef>
-                <a:spcPts val="1000"/>
+                <a:spcPts val="800"/>
               </a:spcBef>
               <a:defRPr sz="2000">
                 <a:solidFill>
@@ -3394,15 +3397,15 @@
               </a:defRPr>
             </a:pPr>
             <a:r>
-              <a:t>The Intelligence Layer Missing at Visakhapatnam — Ready Today.</a:t>
+              <a:t>The Intelligence Layer Missing at Visakhapatnam — Deployed Live Today.</a:t>
             </a:r>
           </a:p>
           <a:p>
             <a:pPr>
               <a:spcBef>
-                <a:spcPts val="1400"/>
+                <a:spcPts val="1200"/>
               </a:spcBef>
-              <a:defRPr sz="1600">
+              <a:defRPr sz="1500" b="0">
                 <a:solidFill>
                   <a:srgbClr val="EEEEEE"/>
                 </a:solidFill>
@@ -3415,9 +3418,9 @@
           <a:p>
             <a:pPr>
               <a:spcBef>
-                <a:spcPts val="1400"/>
+                <a:spcPts val="1200"/>
               </a:spcBef>
-              <a:defRPr sz="1600">
+              <a:defRPr sz="1500" b="0">
                 <a:solidFill>
                   <a:srgbClr val="EEEEEE"/>
                 </a:solidFill>
@@ -3430,22 +3433,22 @@
           <a:p>
             <a:pPr>
               <a:spcBef>
-                <a:spcPts val="1400"/>
+                <a:spcPts val="1200"/>
               </a:spcBef>
-              <a:defRPr sz="1600">
-                <a:solidFill>
-                  <a:srgbClr val="EEEEEE"/>
-                </a:solidFill>
-              </a:defRPr>
-            </a:pPr>
-            <a:r>
-              <a:t>✔ Ready to pilot with one plant's document set today.</a:t>
+              <a:defRPr sz="1500" b="1">
+                <a:solidFill>
+                  <a:srgbClr val="059669"/>
+                </a:solidFill>
+              </a:defRPr>
+            </a:pPr>
+            <a:r>
+              <a:t>✔ 🌐 Live Deployed Application: https://plant-operation-brain-amduv45vm9kibjyjwkwkmh.streamlit.app</a:t>
             </a:r>
           </a:p>
           <a:p>
             <a:pPr>
               <a:spcBef>
-                <a:spcPts val="3000"/>
+                <a:spcPts val="2400"/>
               </a:spcBef>
               <a:defRPr sz="2200" b="1">
                 <a:solidFill>
@@ -3468,7 +3471,7 @@
 </file>
 
 <file path=ppt/slides/slide2.xml><?xml version="1.0" encoding="utf-8"?>
-<p:sld xmlns:a="http://schemas.openxmlformats.org/drawingml/2006/main" xmlns:r="http://schemas.openxmlformats.org/officeDocument/2006/relationships" xmlns:p="http://schemas.openxmlformats.org/presentationml/2006/main">
+<p:sld xmlns:a="http://schemas.openxmlformats.org/drawingml/2006/main" xmlns:p="http://schemas.openxmlformats.org/presentationml/2006/main" xmlns:r="http://schemas.openxmlformats.org/officeDocument/2006/relationships">
   <p:cSld>
     <p:spTree>
       <p:nvGrpSpPr>
@@ -3476,14 +3479,7 @@
         <p:cNvGrpSpPr/>
         <p:nvPr/>
       </p:nvGrpSpPr>
-      <p:grpSpPr>
-        <a:xfrm>
-          <a:off x="0" y="0"/>
-          <a:ext cx="0" cy="0"/>
-          <a:chOff x="0" y="0"/>
-          <a:chExt cx="0" cy="0"/>
-        </a:xfrm>
-      </p:grpSpPr>
+      <p:grpSpPr/>
       <p:sp>
         <p:nvSpPr>
           <p:cNvPr id="2" name="TextBox 1"/>
@@ -3598,7 +3594,6 @@
           <a:lstStyle/>
           <a:p>
             <a:pPr algn="ctr"/>
-            <a:endParaRPr/>
           </a:p>
         </p:txBody>
       </p:sp>
@@ -3694,7 +3689,6 @@
           <a:lstStyle/>
           <a:p>
             <a:pPr algn="ctr"/>
-            <a:endParaRPr/>
           </a:p>
         </p:txBody>
       </p:sp>
@@ -3790,7 +3784,6 @@
           <a:lstStyle/>
           <a:p>
             <a:pPr algn="ctr"/>
-            <a:endParaRPr/>
           </a:p>
         </p:txBody>
       </p:sp>
@@ -3886,7 +3879,6 @@
           <a:lstStyle/>
           <a:p>
             <a:pPr algn="ctr"/>
-            <a:endParaRPr/>
           </a:p>
         </p:txBody>
       </p:sp>
@@ -3948,7 +3940,7 @@
         </p:nvSpPr>
         <p:spPr>
           <a:xfrm>
-            <a:off x="731520" y="6080446"/>
+            <a:off x="731520" y="5943600"/>
             <a:ext cx="10698480" cy="548640"/>
           </a:xfrm>
           <a:prstGeom prst="rect">
@@ -4001,7 +3993,7 @@
 </file>
 
 <file path=ppt/slides/slide3.xml><?xml version="1.0" encoding="utf-8"?>
-<p:sld xmlns:a="http://schemas.openxmlformats.org/drawingml/2006/main" xmlns:r="http://schemas.openxmlformats.org/officeDocument/2006/relationships" xmlns:p="http://schemas.openxmlformats.org/presentationml/2006/main">
+<p:sld xmlns:a="http://schemas.openxmlformats.org/drawingml/2006/main" xmlns:p="http://schemas.openxmlformats.org/presentationml/2006/main" xmlns:r="http://schemas.openxmlformats.org/officeDocument/2006/relationships">
   <p:cSld>
     <p:spTree>
       <p:nvGrpSpPr>
@@ -4009,14 +4001,7 @@
         <p:cNvGrpSpPr/>
         <p:nvPr/>
       </p:nvGrpSpPr>
-      <p:grpSpPr>
-        <a:xfrm>
-          <a:off x="0" y="0"/>
-          <a:ext cx="0" cy="0"/>
-          <a:chOff x="0" y="0"/>
-          <a:chExt cx="0" cy="0"/>
-        </a:xfrm>
-      </p:grpSpPr>
+      <p:grpSpPr/>
       <p:sp>
         <p:nvSpPr>
           <p:cNvPr id="2" name="TextBox 1"/>
@@ -4131,7 +4116,6 @@
           <a:lstStyle/>
           <a:p>
             <a:pPr algn="ctr"/>
-            <a:endParaRPr/>
           </a:p>
         </p:txBody>
       </p:sp>
@@ -4272,7 +4256,6 @@
           <a:lstStyle/>
           <a:p>
             <a:pPr algn="ctr"/>
-            <a:endParaRPr/>
           </a:p>
         </p:txBody>
       </p:sp>
@@ -4395,7 +4378,7 @@
 </file>
 
 <file path=ppt/slides/slide4.xml><?xml version="1.0" encoding="utf-8"?>
-<p:sld xmlns:a="http://schemas.openxmlformats.org/drawingml/2006/main" xmlns:r="http://schemas.openxmlformats.org/officeDocument/2006/relationships" xmlns:p="http://schemas.openxmlformats.org/presentationml/2006/main">
+<p:sld xmlns:a="http://schemas.openxmlformats.org/drawingml/2006/main" xmlns:p="http://schemas.openxmlformats.org/presentationml/2006/main" xmlns:r="http://schemas.openxmlformats.org/officeDocument/2006/relationships">
   <p:cSld>
     <p:spTree>
       <p:nvGrpSpPr>
@@ -4403,14 +4386,7 @@
         <p:cNvGrpSpPr/>
         <p:nvPr/>
       </p:nvGrpSpPr>
-      <p:grpSpPr>
-        <a:xfrm>
-          <a:off x="0" y="0"/>
-          <a:ext cx="0" cy="0"/>
-          <a:chOff x="0" y="0"/>
-          <a:chExt cx="0" cy="0"/>
-        </a:xfrm>
-      </p:grpSpPr>
+      <p:grpSpPr/>
       <p:sp>
         <p:nvSpPr>
           <p:cNvPr id="2" name="TextBox 1"/>
@@ -4528,9 +4504,7 @@
             <a:spAutoFit/>
           </a:bodyPr>
           <a:lstStyle/>
-          <a:p>
-            <a:endParaRPr/>
-          </a:p>
+          <a:p/>
           <a:p>
             <a:pPr>
               <a:spcBef>
@@ -4677,7 +4651,7 @@
 </file>
 
 <file path=ppt/slides/slide5.xml><?xml version="1.0" encoding="utf-8"?>
-<p:sld xmlns:a="http://schemas.openxmlformats.org/drawingml/2006/main" xmlns:r="http://schemas.openxmlformats.org/officeDocument/2006/relationships" xmlns:p="http://schemas.openxmlformats.org/presentationml/2006/main">
+<p:sld xmlns:a="http://schemas.openxmlformats.org/drawingml/2006/main" xmlns:p="http://schemas.openxmlformats.org/presentationml/2006/main" xmlns:r="http://schemas.openxmlformats.org/officeDocument/2006/relationships">
   <p:cSld>
     <p:spTree>
       <p:nvGrpSpPr>
@@ -4685,14 +4659,7 @@
         <p:cNvGrpSpPr/>
         <p:nvPr/>
       </p:nvGrpSpPr>
-      <p:grpSpPr>
-        <a:xfrm>
-          <a:off x="0" y="0"/>
-          <a:ext cx="0" cy="0"/>
-          <a:chOff x="0" y="0"/>
-          <a:chExt cx="0" cy="0"/>
-        </a:xfrm>
-      </p:grpSpPr>
+      <p:grpSpPr/>
       <p:sp>
         <p:nvSpPr>
           <p:cNvPr id="2" name="TextBox 1"/>
@@ -4869,7 +4836,7 @@
 </file>
 
 <file path=ppt/slides/slide6.xml><?xml version="1.0" encoding="utf-8"?>
-<p:sld xmlns:a="http://schemas.openxmlformats.org/drawingml/2006/main" xmlns:r="http://schemas.openxmlformats.org/officeDocument/2006/relationships" xmlns:p="http://schemas.openxmlformats.org/presentationml/2006/main">
+<p:sld xmlns:a="http://schemas.openxmlformats.org/drawingml/2006/main" xmlns:p="http://schemas.openxmlformats.org/presentationml/2006/main" xmlns:r="http://schemas.openxmlformats.org/officeDocument/2006/relationships">
   <p:cSld>
     <p:spTree>
       <p:nvGrpSpPr>
@@ -4877,14 +4844,7 @@
         <p:cNvGrpSpPr/>
         <p:nvPr/>
       </p:nvGrpSpPr>
-      <p:grpSpPr>
-        <a:xfrm>
-          <a:off x="0" y="0"/>
-          <a:ext cx="0" cy="0"/>
-          <a:chOff x="0" y="0"/>
-          <a:chExt cx="0" cy="0"/>
-        </a:xfrm>
-      </p:grpSpPr>
+      <p:grpSpPr/>
       <p:sp>
         <p:nvSpPr>
           <p:cNvPr id="2" name="TextBox 1"/>
@@ -5133,7 +5093,7 @@
 </file>
 
 <file path=ppt/slides/slide7.xml><?xml version="1.0" encoding="utf-8"?>
-<p:sld xmlns:a="http://schemas.openxmlformats.org/drawingml/2006/main" xmlns:r="http://schemas.openxmlformats.org/officeDocument/2006/relationships" xmlns:p="http://schemas.openxmlformats.org/presentationml/2006/main">
+<p:sld xmlns:a="http://schemas.openxmlformats.org/drawingml/2006/main" xmlns:p="http://schemas.openxmlformats.org/presentationml/2006/main" xmlns:r="http://schemas.openxmlformats.org/officeDocument/2006/relationships">
   <p:cSld>
     <p:spTree>
       <p:nvGrpSpPr>
@@ -5141,14 +5101,7 @@
         <p:cNvGrpSpPr/>
         <p:nvPr/>
       </p:nvGrpSpPr>
-      <p:grpSpPr>
-        <a:xfrm>
-          <a:off x="0" y="0"/>
-          <a:ext cx="0" cy="0"/>
-          <a:chOff x="0" y="0"/>
-          <a:chExt cx="0" cy="0"/>
-        </a:xfrm>
-      </p:grpSpPr>
+      <p:grpSpPr/>
       <p:sp>
         <p:nvSpPr>
           <p:cNvPr id="2" name="TextBox 1"/>
@@ -5240,34 +5193,10 @@
                 <a:tableStyleId>{5C22544A-7EE6-4342-B048-85BDC9FD1C3A}</a:tableStyleId>
               </a:tblPr>
               <a:tblGrid>
-                <a:gridCol w="2674620">
-                  <a:extLst>
-                    <a:ext uri="{9D8B030D-6E8A-4147-A177-3AD203B41FA5}">
-                      <a16:colId xmlns:a16="http://schemas.microsoft.com/office/drawing/2014/main" val="20000"/>
-                    </a:ext>
-                  </a:extLst>
-                </a:gridCol>
-                <a:gridCol w="2674620">
-                  <a:extLst>
-                    <a:ext uri="{9D8B030D-6E8A-4147-A177-3AD203B41FA5}">
-                      <a16:colId xmlns:a16="http://schemas.microsoft.com/office/drawing/2014/main" val="20001"/>
-                    </a:ext>
-                  </a:extLst>
-                </a:gridCol>
-                <a:gridCol w="2674620">
-                  <a:extLst>
-                    <a:ext uri="{9D8B030D-6E8A-4147-A177-3AD203B41FA5}">
-                      <a16:colId xmlns:a16="http://schemas.microsoft.com/office/drawing/2014/main" val="20002"/>
-                    </a:ext>
-                  </a:extLst>
-                </a:gridCol>
-                <a:gridCol w="2674620">
-                  <a:extLst>
-                    <a:ext uri="{9D8B030D-6E8A-4147-A177-3AD203B41FA5}">
-                      <a16:colId xmlns:a16="http://schemas.microsoft.com/office/drawing/2014/main" val="20003"/>
-                    </a:ext>
-                  </a:extLst>
-                </a:gridCol>
+                <a:gridCol w="2674620"/>
+                <a:gridCol w="2674620"/>
+                <a:gridCol w="2674620"/>
+                <a:gridCol w="2674620"/>
               </a:tblGrid>
               <a:tr h="470262">
                 <a:tc>
@@ -5276,7 +5205,7 @@
                     <a:lstStyle/>
                     <a:p>
                       <a:pPr>
-                        <a:defRPr sz="1300" b="1">
+                        <a:defRPr b="1" sz="1300">
                           <a:solidFill>
                             <a:srgbClr val="FFFFFF"/>
                           </a:solidFill>
@@ -5299,7 +5228,7 @@
                     <a:lstStyle/>
                     <a:p>
                       <a:pPr>
-                        <a:defRPr sz="1300" b="1">
+                        <a:defRPr b="1" sz="1300">
                           <a:solidFill>
                             <a:srgbClr val="FFFFFF"/>
                           </a:solidFill>
@@ -5322,7 +5251,7 @@
                     <a:lstStyle/>
                     <a:p>
                       <a:pPr>
-                        <a:defRPr sz="1300" b="1">
+                        <a:defRPr b="1" sz="1300">
                           <a:solidFill>
                             <a:srgbClr val="FFFFFF"/>
                           </a:solidFill>
@@ -5345,7 +5274,7 @@
                     <a:lstStyle/>
                     <a:p>
                       <a:pPr>
-                        <a:defRPr sz="1300" b="1">
+                        <a:defRPr b="1" sz="1300">
                           <a:solidFill>
                             <a:srgbClr val="FFFFFF"/>
                           </a:solidFill>
@@ -5362,11 +5291,6 @@
                     </a:solidFill>
                   </a:tcPr>
                 </a:tc>
-                <a:extLst>
-                  <a:ext uri="{0D108BD9-81ED-4DB2-BD59-A6C34878D82A}">
-                    <a16:rowId xmlns:a16="http://schemas.microsoft.com/office/drawing/2014/main" val="10000"/>
-                  </a:ext>
-                </a:extLst>
               </a:tr>
               <a:tr h="470262">
                 <a:tc>
@@ -5461,11 +5385,6 @@
                     </a:solidFill>
                   </a:tcPr>
                 </a:tc>
-                <a:extLst>
-                  <a:ext uri="{0D108BD9-81ED-4DB2-BD59-A6C34878D82A}">
-                    <a16:rowId xmlns:a16="http://schemas.microsoft.com/office/drawing/2014/main" val="10001"/>
-                  </a:ext>
-                </a:extLst>
               </a:tr>
               <a:tr h="470262">
                 <a:tc>
@@ -5560,11 +5479,6 @@
                     </a:solidFill>
                   </a:tcPr>
                 </a:tc>
-                <a:extLst>
-                  <a:ext uri="{0D108BD9-81ED-4DB2-BD59-A6C34878D82A}">
-                    <a16:rowId xmlns:a16="http://schemas.microsoft.com/office/drawing/2014/main" val="10002"/>
-                  </a:ext>
-                </a:extLst>
               </a:tr>
               <a:tr h="470262">
                 <a:tc>
@@ -5659,11 +5573,6 @@
                     </a:solidFill>
                   </a:tcPr>
                 </a:tc>
-                <a:extLst>
-                  <a:ext uri="{0D108BD9-81ED-4DB2-BD59-A6C34878D82A}">
-                    <a16:rowId xmlns:a16="http://schemas.microsoft.com/office/drawing/2014/main" val="10003"/>
-                  </a:ext>
-                </a:extLst>
               </a:tr>
               <a:tr h="470262">
                 <a:tc>
@@ -5758,11 +5667,6 @@
                     </a:solidFill>
                   </a:tcPr>
                 </a:tc>
-                <a:extLst>
-                  <a:ext uri="{0D108BD9-81ED-4DB2-BD59-A6C34878D82A}">
-                    <a16:rowId xmlns:a16="http://schemas.microsoft.com/office/drawing/2014/main" val="10004"/>
-                  </a:ext>
-                </a:extLst>
               </a:tr>
               <a:tr h="470262">
                 <a:tc>
@@ -5857,11 +5761,6 @@
                     </a:solidFill>
                   </a:tcPr>
                 </a:tc>
-                <a:extLst>
-                  <a:ext uri="{0D108BD9-81ED-4DB2-BD59-A6C34878D82A}">
-                    <a16:rowId xmlns:a16="http://schemas.microsoft.com/office/drawing/2014/main" val="10005"/>
-                  </a:ext>
-                </a:extLst>
               </a:tr>
               <a:tr h="470268">
                 <a:tc>
@@ -5956,11 +5855,6 @@
                     </a:solidFill>
                   </a:tcPr>
                 </a:tc>
-                <a:extLst>
-                  <a:ext uri="{0D108BD9-81ED-4DB2-BD59-A6C34878D82A}">
-                    <a16:rowId xmlns:a16="http://schemas.microsoft.com/office/drawing/2014/main" val="10006"/>
-                  </a:ext>
-                </a:extLst>
               </a:tr>
             </a:tbl>
           </a:graphicData>
@@ -6029,7 +5923,7 @@
 </file>
 
 <file path=ppt/slides/slide8.xml><?xml version="1.0" encoding="utf-8"?>
-<p:sld xmlns:a="http://schemas.openxmlformats.org/drawingml/2006/main" xmlns:r="http://schemas.openxmlformats.org/officeDocument/2006/relationships" xmlns:p="http://schemas.openxmlformats.org/presentationml/2006/main">
+<p:sld xmlns:a="http://schemas.openxmlformats.org/drawingml/2006/main" xmlns:p="http://schemas.openxmlformats.org/presentationml/2006/main" xmlns:r="http://schemas.openxmlformats.org/officeDocument/2006/relationships">
   <p:cSld>
     <p:spTree>
       <p:nvGrpSpPr>
@@ -6037,14 +5931,7 @@
         <p:cNvGrpSpPr/>
         <p:nvPr/>
       </p:nvGrpSpPr>
-      <p:grpSpPr>
-        <a:xfrm>
-          <a:off x="0" y="0"/>
-          <a:ext cx="0" cy="0"/>
-          <a:chOff x="0" y="0"/>
-          <a:chExt cx="0" cy="0"/>
-        </a:xfrm>
-      </p:grpSpPr>
+      <p:grpSpPr/>
       <p:sp>
         <p:nvSpPr>
           <p:cNvPr id="2" name="TextBox 1"/>
@@ -6159,7 +6046,6 @@
           <a:lstStyle/>
           <a:p>
             <a:pPr algn="ctr"/>
-            <a:endParaRPr/>
           </a:p>
         </p:txBody>
       </p:sp>
@@ -6255,7 +6141,6 @@
           <a:lstStyle/>
           <a:p>
             <a:pPr algn="ctr"/>
-            <a:endParaRPr/>
           </a:p>
         </p:txBody>
       </p:sp>
@@ -6351,7 +6236,6 @@
           <a:lstStyle/>
           <a:p>
             <a:pPr algn="ctr"/>
-            <a:endParaRPr/>
           </a:p>
         </p:txBody>
       </p:sp>
@@ -6447,7 +6331,6 @@
           <a:lstStyle/>
           <a:p>
             <a:pPr algn="ctr"/>
-            <a:endParaRPr/>
           </a:p>
         </p:txBody>
       </p:sp>
@@ -6510,7 +6393,7 @@
 </file>
 
 <file path=ppt/slides/slide9.xml><?xml version="1.0" encoding="utf-8"?>
-<p:sld xmlns:a="http://schemas.openxmlformats.org/drawingml/2006/main" xmlns:r="http://schemas.openxmlformats.org/officeDocument/2006/relationships" xmlns:p="http://schemas.openxmlformats.org/presentationml/2006/main">
+<p:sld xmlns:a="http://schemas.openxmlformats.org/drawingml/2006/main" xmlns:p="http://schemas.openxmlformats.org/presentationml/2006/main" xmlns:r="http://schemas.openxmlformats.org/officeDocument/2006/relationships">
   <p:cSld>
     <p:spTree>
       <p:nvGrpSpPr>
@@ -6518,14 +6401,7 @@
         <p:cNvGrpSpPr/>
         <p:nvPr/>
       </p:nvGrpSpPr>
-      <p:grpSpPr>
-        <a:xfrm>
-          <a:off x="0" y="0"/>
-          <a:ext cx="0" cy="0"/>
-          <a:chOff x="0" y="0"/>
-          <a:chExt cx="0" cy="0"/>
-        </a:xfrm>
-      </p:grpSpPr>
+      <p:grpSpPr/>
       <p:sp>
         <p:nvSpPr>
           <p:cNvPr id="2" name="TextBox 1"/>
@@ -6640,7 +6516,6 @@
           <a:lstStyle/>
           <a:p>
             <a:pPr algn="ctr"/>
-            <a:endParaRPr/>
           </a:p>
         </p:txBody>
       </p:sp>
@@ -6736,7 +6611,6 @@
           <a:lstStyle/>
           <a:p>
             <a:pPr algn="ctr"/>
-            <a:endParaRPr/>
           </a:p>
         </p:txBody>
       </p:sp>
@@ -6832,7 +6706,6 @@
           <a:lstStyle/>
           <a:p>
             <a:pPr algn="ctr"/>
-            <a:endParaRPr/>
           </a:p>
         </p:txBody>
       </p:sp>

</xml_diff>